<commit_message>
Loosen the script's register and add a bilingual Word version
Rewrote the spoken script so it sounds like speech rather than read
prose — contractions, shorter sentences, direct address — while keeping
the vocabulary and hedging of a conference talk ("we're open about the
limits", "the reason is mechanical, not mysterious"). Every slide's
speaker notes are regenerated from the same source, so the deck and the
script cannot drift apart.

The rewrite ran about 95 words long, so it was trimmed back; the talk is
about 10:15 at 130 wpm, with roughly 65 words marked droppable to reach
9:45 if the chair is strict.

New deliverable: ICAC2026_Paper108_Script_EN-CN.docx — the script alone,
English left, Chinese right, aligned paragraph by paragraph, A4
landscape. Semantic correspondence only: no delivery cues, no timings,
no backup-slide notes.

Co-Authored-By: Claude Opus 5 <noreply@anthropic.com>
Claude-Session: https://claude.ai/code/session_01FFZ9SAYorLnu9PY8BMiyFp
</commit_message>
<xml_diff>
--- a/docs/icac2026/ICAC2026_Paper108_Valentown.pptx
+++ b/docs/icac2026/ICAC2026_Paper108_Valentown.pptx
@@ -516,7 +516,7 @@
           <a:p>
             <a:r>
               <a:rPr lang="en-US" dirty="0"/>
-              <a:t>Good afternoon. I'm Aoao Guo, from University College London, and this is joint work with Xinyi Tao, Huakang Li and Xuewu Dai. We present a lightweight, LLM-driven multi-agent framework for simulating a virtual society, built around a memory feedback loop. Our system is a small town called Valentown, with seven residents who plan their own days, meet each other, remember what happened, and adapt because of it.</a:t>
+              <a:t>Good afternoon. I'm Aoao Guo, from University College London, and this is joint work with Xinyi Tao, Huakang Li and Xuewu Dai. We've built a lightweight, LLM-driven multi-agent framework for simulating a virtual society, and the piece that holds it together is a memory feedback loop. The system is a small town called Valentown, where seven residents plan their own days, run into each other, remember what happened, and change what they do because of it.</a:t>
             </a:r>
             <a:endParaRPr lang="en-US" dirty="0"/>
           </a:p>
@@ -605,8 +605,8 @@
             <a:r>
               <a:rPr lang="en-US" dirty="0"/>
               <a:t>The second result is about memory over time.
-Memory content does not stay the same. Early on it is mostly plans and observations. As the days pass, conversations and reflections become prominent. Later, high-importance interaction and reflection memories form the dominant context for new decisions — the store turns from a log of activity into accumulated experience.
-And that content tracks behaviour. Agents with rich interaction and reflection memories adapt more and behave more coherently. Repeated interaction between two agents forms a persistent bond, visible later as repeated co-location. Nobody wrote a friendship rule; it comes out of memory plus retrieval. Where memory influence is limited, adaptation is weaker.</a:t>
+The content of memory doesn't stay the same. Early on it's mostly plans and observations. As the days pass, conversations and reflections become more prominent. Later still, the high-importance interaction and reflection memories form the dominant context for new decisions — the store turns from a log of activity into accumulated experience.
+And that content tracks behaviour. Agents with rich interaction and reflection memories adapt more and behave more coherently. Repeated interaction between two agents forms a persistent bond, which shows up later as repeated co-location. Nobody wrote a friendship rule; it comes out of memory plus retrieval. Where memory influence is limited, adaptation is weaker.</a:t>
             </a:r>
             <a:endParaRPr lang="en-US" dirty="0"/>
           </a:p>
@@ -694,10 +694,10 @@
           <a:p>
             <a:r>
               <a:rPr lang="en-US" dirty="0"/>
-              <a:t>To conclude. We presented a schedule-driven multi-agent framework in which planning, interaction and reflection are linked through a memory-centred feedback loop. Importance-based memory keeps what mattered, and reflection turns it into insight that guides the next day.
-The experiments show these simple mechanisms are enough: agents develop consistent routines, form lasting relationships and adapt from experience, with no hand-written behavioural rules.
-We are open about the limits. Every plan, conversation and reflection is an API call, so cost scales with agents times days; the study is small; and generated output varies between runs, which is why our evaluation is qualitative.
-That sets the agenda: quantitative evaluation first, then scale and real-time reaction, then deeper reasoning — with applications to game NPCs, education and embodied agents.</a:t>
+              <a:t>To conclude. We've presented a schedule-driven multi-agent framework where planning, interaction and reflection are linked through a memory-centred feedback loop. Importance-based memory keeps what mattered, and reflection turns it into insight that guides the next day.
+What the experiments show is that these simple mechanisms are enough: agents develop consistent routines, form lasting relationships, and adapt from experience — with no hand-written behavioural rules anywhere.
+We're open about the limits. Every plan, conversation and reflection is an API call, so cost scales with agents times days; the study is small; and output varies between runs, which is why our evaluation is qualitative for now.
+And that sets the agenda: quantitative evaluation first, then scale and real-time reaction, then deeper reasoning — with applications to game NPCs, education, and embodied agents.</a:t>
             </a:r>
             <a:endParaRPr lang="en-US" dirty="0"/>
           </a:p>
@@ -785,8 +785,7 @@
           <a:p>
             <a:r>
               <a:rPr lang="en-US" dirty="0"/>
-              <a:t>Thank you very much for your attention. I am happy to take questions.
-(Three backup slides follow: architecture, the client as a still image, and the full advantages/limitations.)</a:t>
+              <a:t>Thank you very much for your attention. I'm happy to take questions.</a:t>
             </a:r>
             <a:endParaRPr lang="en-US" dirty="0"/>
           </a:p>
@@ -874,7 +873,7 @@
           <a:p>
             <a:r>
               <a:rPr lang="en-US" dirty="0"/>
-              <a:t>BACKUP. Use if asked how the system is put together. The backend, in Python, does planning, dialogue, reflection and memory management, and is the only part that calls the language model — through the DeepSeek API. The frontend, in Phaser, renders the town over a REST interface. Five modules underneath — Agent Manager, Scheduler, Interaction Engine, LLM Interface, Memory Manager — each replaceable on its own.</a:t>
+              <a:t>BACKUP. Use if someone asks how the system is put together. The backend, in Python, does the planning, the dialogue, the reflection and the memory management, and it's the only part that calls the language model — through the DeepSeek API. The frontend, in Phaser, renders the town over a REST interface. Five modules underneath — Agent Manager, Scheduler, Interaction Engine, LLM Interface, Memory Manager — each replaceable on its own.</a:t>
             </a:r>
             <a:endParaRPr lang="en-US" dirty="0"/>
           </a:p>
@@ -962,7 +961,7 @@
           <a:p>
             <a:r>
               <a:rPr lang="en-US" dirty="0"/>
-              <a:t>BACKUP — and the fallback if the video will not play. This is the same client as a still image: talk through it exactly as you would have talked over the video.</a:t>
+              <a:t>BACKUP — and the fallback if the video won't play. This is the same client as a still image: talk through it exactly as you would have talked over the video.</a:t>
             </a:r>
             <a:endParaRPr lang="en-US" dirty="0"/>
           </a:p>
@@ -1050,7 +1049,7 @@
           <a:p>
             <a:r>
               <a:rPr lang="en-US" dirty="0"/>
-              <a:t>BACKUP. The full advantages and limitations, if the discussion goes there. Lightweight and reproducible (explicit pipeline, deterministic triggers); controllable (schedules, co-location rules, human feedback); extendable (every module swaps independently). Against: cost that scales with agents times days, a small-scale study, and run-to-run variation that makes strict quantitative evaluation hard.</a:t>
+              <a:t>BACKUP. The full advantages and limitations, if the discussion goes there. Lightweight and reproducible (explicit pipeline, deterministic triggers); controllable (schedules, co-location rules, human feedback); extendable (every module swaps independently). Against that: cost that scales with agents times days, a small-scale study, and run-to-run variation that makes strict quantitative evaluation hard.</a:t>
             </a:r>
             <a:endParaRPr lang="en-US" dirty="0"/>
           </a:p>
@@ -1138,9 +1137,9 @@
           <a:p>
             <a:r>
               <a:rPr lang="en-US" dirty="0"/>
-              <a:t>Multi-agent simulation is the standard way to model complex systems: social networks, transport, smart cities. But classical agent-based models run on predefined rules. They capture macro patterns well and human behaviour badly — no context, no planning, no memory.
-Large language models changed what an agent can do. An LLM agent produces coherent language, keeps context, and imitates parts of human reasoning.
-But something is still missing. Most LLM agent systems are reactive: they answer the prompt in front of them. There is no daily structure, and interaction is ad hoc. So behaviour drifts, the dynamics are hard to control, and results are hard to reproduce. That is the gap we target.</a:t>
+              <a:t>Multi-agent simulation is how we've modelled complex systems for decades — social networks, transport, smart cities. But classical agent-based models run on predefined rules, and it shows: good at macro patterns, poor at human behaviour. No context, no planning, no memory.
+Large language models changed what one agent can do. An LLM agent produces coherent language, holds context, and imitates parts of human reasoning.
+But something is still missing. Most LLM agent systems are reactive — they answer whatever prompt is in front of them. There's no structure to the day, and interaction is ad hoc. So behaviour drifts, the dynamics are hard to control, and results are hard to reproduce. That's the gap we're targeting.</a:t>
             </a:r>
             <a:endParaRPr lang="en-US" dirty="0"/>
           </a:p>
@@ -1228,11 +1227,11 @@
           <a:p>
             <a:r>
               <a:rPr lang="en-US" dirty="0"/>
-              <a:t>Our question is: how do we design a virtual society where agents are structured, evolving and controllable at the same time?
-That breaks into three requirements, and each one is answered by one mechanism. These are also our three contributions.
+              <a:t>So the question we set ourselves is this: how do you design a virtual society where the agents are structured, evolving and controllable — all three at once?
+That breaks into three requirements, each answered by one mechanism — and those are our three contributions.
 Temporal structure: behaviour has to be organised as a day. Our answer is a schedule-driven agent design.
 Evolution: yesterday has to change tomorrow. Our answer is a memory-based feedback loop.
-Controllability: interaction must follow an explicit rule, and a human should be able to step in. Our answer is a deterministic co-location trigger, plus optional human-in-the-loop feedback.</a:t>
+Controllability: interaction should follow an explicit rule, and a person should be able to step in. Our answer is a deterministic co-location trigger, plus optional human-in-the-loop feedback.</a:t>
             </a:r>
             <a:endParaRPr lang="en-US" dirty="0"/>
           </a:p>
@@ -1321,9 +1320,9 @@
             <a:r>
               <a:rPr lang="en-US" dirty="0"/>
               <a:t>The first two mechanisms.
-Schedule-driven behaviour. Instead of asking an agent what to do at every moment, the day starts with an explicit schedule. The prompt combines identity, personality and goals with memories retrieved as context, and the model returns activities and the destinations they imply. That is what makes routines coherent over time, and interpretable for us.
-Second, interaction. We do not sample conversations at random. Two agents talk when they are in the same place in the same period — plain co-location. The rule is deterministic, so the social dynamics are reproducible; what gets said is still generated by the model.
-That is the design principle of the paper: deterministic when, generative what.</a:t>
+Start with schedule-driven behaviour. Rather than asking an agent what to do at every moment, we let the day begin with an explicit schedule. The prompt combines identity, personality and goals with memories retrieved as context, and the model gives back activities and the destinations they imply. That's what keeps routines coherent over time — and interpretable for us.
+Second, interaction. We don't sample conversations at random. Two agents talk when they're in the same place in the same period — plain co-location. Because the trigger is deterministic, the social dynamics are reproducible; what gets said is still generated by the model.
+That's the design principle of the whole paper: deterministic when, generative what.</a:t>
             </a:r>
             <a:endParaRPr lang="en-US" dirty="0"/>
           </a:p>
@@ -1411,11 +1410,11 @@
           <a:p>
             <a:r>
               <a:rPr lang="en-US" dirty="0"/>
-              <a:t>The third mechanism, and the heart of the paper: memory.
-Everything an agent produces goes into one store. Plans are kept as behavioural records, conversations as social experience, reflections as summaries. Every entry has a category, a timestamp and an importance score.
-And everything reads from that store. Planning retrieves relevant memories, dialogue retrieves recent history, and reflection summarises the important ones into compact insight and writes it back. That is the loop in the figure.
-Retrieval favours recent and high-importance entries, and the store stays bounded, so agents keep what mattered.
-Two notes. A person can write feedback directly into memory, through the same channel. And the language model itself is stateless — all continuity lives in the memory system.</a:t>
+              <a:t>The third mechanism, and really the heart of the paper: memory.
+Everything an agent produces goes into one store. Plans are kept as behavioural records, conversations as social experience, reflections as summaries. Every entry carries a category, a timestamp and an importance score.
+And everything reads from that same store. Planning retrieves relevant memories; dialogue retrieves recent history; reflection takes the important ones, compresses them into a short insight, and writes it back. That's the loop in the figure.
+Retrieval favours what's recent or important, and the store stays bounded, so what an agent keeps is what mattered.
+Two things worth adding. A person can write feedback into memory through that same channel. And the model itself is stateless — all the continuity lives in the memory system.</a:t>
             </a:r>
             <a:endParaRPr lang="en-US" dirty="0"/>
           </a:p>
@@ -1503,9 +1502,9 @@
           <a:p>
             <a:r>
               <a:rPr lang="en-US" dirty="0"/>
-              <a:t>One look at the loop as the system actually runs it.
-Agents initialise from their profile and their memory. On day one there is nothing to reflect on, so they plan straight from the profile; on every later day they reflect on memory first, and that reflection feeds the planning call.
-Then: generate the plan, store it, pick the destination, move, and talk if someone else is there — and the conversation goes back into memory. A closed loop.
+              <a:t>Before the demo, one look at that loop as the system runs it.
+An agent initialises from its profile and its memory. On day one there's nothing to reflect on yet, so it plans straight from the profile; on every later day it reflects on memory first, and that reflection feeds the planning call.
+From there: generate the plan, store it, pick the destination, move, and talk if someone else is there — and the conversation goes back into memory. A closed loop.
 Let me show you that running.</a:t>
             </a:r>
             <a:endParaRPr lang="en-US" dirty="0"/>
@@ -1595,10 +1594,10 @@
             <a:r>
               <a:rPr lang="en-US" dirty="0"/>
               <a:t>▶ INSERT THE VIDEO OVER THE FRAME BEFORE THE TALK. Set it to start automatically, and check the sound is muted. Roughly 180 words over two minutes — leave gaps and let the town play.
-[start] So that is the loop. Here it is running.
-This is Valentown. The whole town is on one plane: homes along the top, the café, supermarket and pharmacy below, a park on the left. Everything you see was produced by the Python backend — planning, dialogue and reflection, and the only calls to DeepSeek — and the client simply replays it.
-[~20 s] Watch one resident. He wakes at home, and the schedule he generated at the start of the day sends him out to a destination. Nobody is steering him.
-[~50 s] Here two residents arrive at the same place in the same period — that is the co-location trigger firing. What they say is generated from their context and recent memory, and it goes straight back into memory.
+[start] So that's the loop. Here it is running.
+This is Valentown. The whole town sits on one plane: homes along the top, the café, the supermarket and the pharmacy below, a park on the left. Everything you're seeing was produced by the Python backend — the planning, the dialogue and the reflection, and the only calls to DeepSeek — and the client simply replays it.
+[~20 s] Watch one resident. He wakes up at home, and the schedule he generated at the start of the day sends him out to a destination. Nobody is steering him.
+[~50 s] Here two residents arrive at the same place in the same period — that's the co-location trigger firing. What they say is generated from their context and their recent memory, and it goes straight back into memory.
 [~1:30] And at the end of the day each agent reflects on what happened — the step you just saw in the flow chart — and that reflection is what tomorrow's plan is built on.
 [end] So the schedule, the trigger and the memory loop — everything from the last four slides — this is all of it, running.</a:t>
             </a:r>
@@ -1688,9 +1687,9 @@
           <a:p>
             <a:r>
               <a:rPr lang="en-US" dirty="0"/>
-              <a:t>For the experiments we use seven agents: a supermarket owner, a pharmacist, a couple with a seven-year-old, a family teacher and an architect. Their attributes ground everything the model generates.
-We run multiple consecutive virtual days, each a full cycle. Scheduling is deterministic while the generated content is stochastic — a reproducible pipeline with diverse behaviour inside it.
-And we ask three questions: what interaction does, what memory does, and whether social structure emerges.</a:t>
+              <a:t>For the experiments we instantiate the framework with seven agents: a supermarket owner, a pharmacist, a couple with a seven-year-old, a family teacher and an architect. Their attributes ground everything the model generates.
+We run several consecutive virtual days, each one a full cycle. Scheduling is deterministic while the content is stochastic — a reproducible pipeline with diverse behaviour inside it.
+And we're asking three questions: what interaction does, what memory does, and whether social structure emerges on its own.</a:t>
             </a:r>
             <a:endParaRPr lang="en-US" dirty="0"/>
           </a:p>
@@ -1779,9 +1778,9 @@
             <a:r>
               <a:rPr lang="en-US" dirty="0"/>
               <a:t>The first experiment is an ablation on interaction.
-With interaction on, agents produce richer and more varied behaviour. The reason is mechanical: a conversation puts new context into memory, and memory is an input to the next plan. So what someone said to you yesterday shows up in what you do today. We see agents scheduling follow-ups, returning to the same places, and repeated contact reinforcing specific pairs.
-With interaction off, the town goes quiet. No new social information enters the system, agents fall back on their initial goals, and schedules stay static across days.
-So interaction is not decoration here — it drives diversity and adaptation together.</a:t>
+With interaction on, agents produce noticeably richer and more varied behaviour. The reason is mechanical, not mysterious: a conversation puts new context into memory, and memory is an input to the next plan. So what someone said to you yesterday shows up in what you do today. We see agents scheduling follow-ups, going back to the same places, and repeated contact reinforcing particular pairs.
+With interaction off, the town goes quiet. No new social information enters at all, so agents fall back on their initial goals, and schedules stay static day to day.
+So interaction isn't decoration here — it drives diversity and adaptation at the same time.</a:t>
             </a:r>
             <a:endParaRPr lang="en-US" dirty="0"/>
           </a:p>

</xml_diff>

<commit_message>
Cut the script by 26% and simplify the sentences
Rewrote every slide's script shorter and plainer: 1,269 words to 942,
a 26% cut. The technical vocabulary is unchanged — what went is the
scaffolding around it. Long sentences were split, subordinate clauses
dropped, and hedges like "and, just as usefully" or "really the heart of
the paper" removed. "Plans are kept as behavioural records, conversations
as social experience, reflections as summaries" became "plans,
conversations, reflections".

The talk is now about 9:05 at an unhurried 115 words per minute,
including the video, so the slack exists to be spoken into rather than
filled. The droppable-sentence markers are gone with it — there is
nothing left worth cutting.

Deck speaker notes and the bilingual Word document are regenerated from
the same source.

Co-Authored-By: Claude Opus 5 <noreply@anthropic.com>
Claude-Session: https://claude.ai/code/session_01FFZ9SAYorLnu9PY8BMiyFp
</commit_message>
<xml_diff>
--- a/docs/icac2026/ICAC2026_Paper108_Valentown.pptx
+++ b/docs/icac2026/ICAC2026_Paper108_Valentown.pptx
@@ -516,7 +516,7 @@
           <a:p>
             <a:r>
               <a:rPr lang="en-US" dirty="0"/>
-              <a:t>Good afternoon. I'm Aoao Guo, from University College London, and this is joint work with Xinyi Tao, Huakang Li and Xuewu Dai. We've built a lightweight, LLM-driven multi-agent framework for simulating a virtual society, and the piece that holds it together is a memory feedback loop. The system is a small town called Valentown, where seven residents plan their own days, run into each other, remember what happened, and change what they do because of it.</a:t>
+              <a:t>Good afternoon. I'm Aoao Guo from University College London, with Xinyi Tao, Huakang Li and Xuewu Dai. We've built a lightweight multi-agent framework that simulates a virtual society, driven by a large language model. It's a small town called Valentown. Seven residents plan their own days, meet each other, remember what happened, and change what they do next.</a:t>
             </a:r>
             <a:endParaRPr lang="en-US" dirty="0"/>
           </a:p>
@@ -604,9 +604,9 @@
           <a:p>
             <a:r>
               <a:rPr lang="en-US" dirty="0"/>
-              <a:t>The second result is about memory over time.
-The content of memory doesn't stay the same. Early on it's mostly plans and observations. As the days pass, conversations and reflections become more prominent. Later still, the high-importance interaction and reflection memories form the dominant context for new decisions — the store turns from a log of activity into accumulated experience.
-And that content tracks behaviour. Agents with rich interaction and reflection memories adapt more and behave more coherently. Repeated interaction between two agents forms a persistent bond, which shows up later as repeated co-location. Nobody wrote a friendship rule; it comes out of memory plus retrieval. Where memory influence is limited, adaptation is weaker.</a:t>
+              <a:t>The second result is memory over time.
+Memory changes shape. Early on it's mostly plans and observations. Then conversations and reflections take over. Later, high-importance memories dominate the context for new decisions — a log becomes experience.
+And that tracks behaviour. Agents with rich memories adapt more and act more coherently. Two agents who meet repeatedly form a lasting bond, visible later as repeated co-location. Nobody wrote a friendship rule; it comes from memory and retrieval.</a:t>
             </a:r>
             <a:endParaRPr lang="en-US" dirty="0"/>
           </a:p>
@@ -694,10 +694,10 @@
           <a:p>
             <a:r>
               <a:rPr lang="en-US" dirty="0"/>
-              <a:t>To conclude. We've presented a schedule-driven multi-agent framework where planning, interaction and reflection are linked through a memory-centred feedback loop. Importance-based memory keeps what mattered, and reflection turns it into insight that guides the next day.
-What the experiments show is that these simple mechanisms are enough: agents develop consistent routines, form lasting relationships, and adapt from experience — with no hand-written behavioural rules anywhere.
-We're open about the limits. Every plan, conversation and reflection is an API call, so cost scales with agents times days; the study is small; and output varies between runs, which is why our evaluation is qualitative for now.
-And that sets the agenda: quantitative evaluation first, then scale and real-time reaction, then deeper reasoning — with applications to game NPCs, education, and embodied agents.</a:t>
+              <a:t>To conclude. We presented a schedule-driven framework where planning, interaction and reflection are linked by one memory loop. Importance-based memory keeps what mattered; reflection turns it into guidance for the next day.
+The experiments show that simple mechanisms are enough. Agents build routines, form lasting relationships, and adapt from experience — with no hand-written rules.
+We're open about the limits. Every plan, conversation and reflection is an API call, so cost grows with agents times days. The study is small. Output varies between runs, so our evaluation is qualitative for now.
+Next: quantitative evaluation, then scale and real time, then deeper reasoning.</a:t>
             </a:r>
             <a:endParaRPr lang="en-US" dirty="0"/>
           </a:p>
@@ -785,7 +785,7 @@
           <a:p>
             <a:r>
               <a:rPr lang="en-US" dirty="0"/>
-              <a:t>Thank you very much for your attention. I'm happy to take questions.</a:t>
+              <a:t>Thank you. I'm happy to take questions.</a:t>
             </a:r>
             <a:endParaRPr lang="en-US" dirty="0"/>
           </a:p>
@@ -873,7 +873,7 @@
           <a:p>
             <a:r>
               <a:rPr lang="en-US" dirty="0"/>
-              <a:t>BACKUP. Use if someone asks how the system is put together. The backend, in Python, does the planning, the dialogue, the reflection and the memory management, and it's the only part that calls the language model — through the DeepSeek API. The frontend, in Phaser, renders the town over a REST interface. Five modules underneath — Agent Manager, Scheduler, Interaction Engine, LLM Interface, Memory Manager — each replaceable on its own.</a:t>
+              <a:t>BACKUP. Use if someone asks how the system is put together. The backend, in Python, does the planning, the dialogue, the reflection and the memory, and it's the only part that calls the model — through the DeepSeek API. The frontend, in Phaser, renders the town over REST. Five modules underneath — Agent Manager, Scheduler, Interaction Engine, LLM Interface, Memory Manager — each replaceable on its own.</a:t>
             </a:r>
             <a:endParaRPr lang="en-US" dirty="0"/>
           </a:p>
@@ -961,7 +961,7 @@
           <a:p>
             <a:r>
               <a:rPr lang="en-US" dirty="0"/>
-              <a:t>BACKUP — and the fallback if the video won't play. This is the same client as a still image: talk through it exactly as you would have talked over the video.</a:t>
+              <a:t>BACKUP — and the fallback if the video won't play. Same client, as a still image: talk through it exactly as you would have talked over the video.</a:t>
             </a:r>
             <a:endParaRPr lang="en-US" dirty="0"/>
           </a:p>
@@ -1049,7 +1049,7 @@
           <a:p>
             <a:r>
               <a:rPr lang="en-US" dirty="0"/>
-              <a:t>BACKUP. The full advantages and limitations, if the discussion goes there. Lightweight and reproducible (explicit pipeline, deterministic triggers); controllable (schedules, co-location rules, human feedback); extendable (every module swaps independently). Against that: cost that scales with agents times days, a small-scale study, and run-to-run variation that makes strict quantitative evaluation hard.</a:t>
+              <a:t>BACKUP. The full advantages and limitations, if the discussion goes there. Lightweight and reproducible; controllable; extendable. Against that: cost that grows with agents times days, a small study, and run-to-run variation that makes strict quantitative evaluation hard.</a:t>
             </a:r>
             <a:endParaRPr lang="en-US" dirty="0"/>
           </a:p>
@@ -1137,9 +1137,9 @@
           <a:p>
             <a:r>
               <a:rPr lang="en-US" dirty="0"/>
-              <a:t>Multi-agent simulation is how we've modelled complex systems for decades — social networks, transport, smart cities. But classical agent-based models run on predefined rules, and it shows: good at macro patterns, poor at human behaviour. No context, no planning, no memory.
-Large language models changed what one agent can do. An LLM agent produces coherent language, holds context, and imitates parts of human reasoning.
-But something is still missing. Most LLM agent systems are reactive — they answer whatever prompt is in front of them. There's no structure to the day, and interaction is ad hoc. So behaviour drifts, the dynamics are hard to control, and results are hard to reproduce. That's the gap we're targeting.</a:t>
+              <a:t>Multi-agent simulation is how we model complex systems: social networks, transport, smart cities. But classical models run on fixed rules. They capture macro patterns well and human behaviour poorly. No context, no planning, no memory.
+Large language models changed that. An LLM agent writes coherent language, holds context, and imitates parts of human reasoning.
+But most LLM agents are reactive. They answer the prompt in front of them. There's no structure to the day, and interaction is ad hoc. So behaviour drifts, control is hard, and results don't reproduce. That's our gap.</a:t>
             </a:r>
             <a:endParaRPr lang="en-US" dirty="0"/>
           </a:p>
@@ -1227,11 +1227,11 @@
           <a:p>
             <a:r>
               <a:rPr lang="en-US" dirty="0"/>
-              <a:t>So the question we set ourselves is this: how do you design a virtual society where the agents are structured, evolving and controllable — all three at once?
-That breaks into three requirements, each answered by one mechanism — and those are our three contributions.
-Temporal structure: behaviour has to be organised as a day. Our answer is a schedule-driven agent design.
-Evolution: yesterday has to change tomorrow. Our answer is a memory-based feedback loop.
-Controllability: interaction should follow an explicit rule, and a person should be able to step in. Our answer is a deterministic co-location trigger, plus optional human-in-the-loop feedback.</a:t>
+              <a:t>So our question is simple: how do we make agents structured, evolving and controllable at the same time?
+Three requirements, three mechanisms — and those are our contributions.
+Structure: behaviour has to be organised as a day. Our answer is schedule-driven agents.
+Evolution: yesterday has to change tomorrow. Our answer is a memory feedback loop.
+Control: interaction needs an explicit rule, and a person should be able to step in. Our answer is a co-location trigger, plus optional human feedback.</a:t>
             </a:r>
             <a:endParaRPr lang="en-US" dirty="0"/>
           </a:p>
@@ -1320,9 +1320,9 @@
             <a:r>
               <a:rPr lang="en-US" dirty="0"/>
               <a:t>The first two mechanisms.
-Start with schedule-driven behaviour. Rather than asking an agent what to do at every moment, we let the day begin with an explicit schedule. The prompt combines identity, personality and goals with memories retrieved as context, and the model gives back activities and the destinations they imply. That's what keeps routines coherent over time — and interpretable for us.
-Second, interaction. We don't sample conversations at random. Two agents talk when they're in the same place in the same period — plain co-location. Because the trigger is deterministic, the social dynamics are reproducible; what gets said is still generated by the model.
-That's the design principle of the whole paper: deterministic when, generative what.</a:t>
+Schedule-driven behaviour. The day starts with a plan, not with a reaction. The prompt combines identity, personality and goals with retrieved memories, and the model returns activities and destinations. Routines stay coherent, and we can read them.
+Interaction. We don't sample conversations at random. Two agents talk when they're in the same place at the same time. The trigger is deterministic, so the dynamics are reproducible; the content still comes from the model.
+That's our design principle: deterministic when, generative what.</a:t>
             </a:r>
             <a:endParaRPr lang="en-US" dirty="0"/>
           </a:p>
@@ -1410,11 +1410,11 @@
           <a:p>
             <a:r>
               <a:rPr lang="en-US" dirty="0"/>
-              <a:t>The third mechanism, and really the heart of the paper: memory.
-Everything an agent produces goes into one store. Plans are kept as behavioural records, conversations as social experience, reflections as summaries. Every entry carries a category, a timestamp and an importance score.
-And everything reads from that same store. Planning retrieves relevant memories; dialogue retrieves recent history; reflection takes the important ones, compresses them into a short insight, and writes it back. That's the loop in the figure.
-Retrieval favours what's recent or important, and the store stays bounded, so what an agent keeps is what mattered.
-Two things worth adding. A person can write feedback into memory through that same channel. And the model itself is stateless — all the continuity lives in the memory system.</a:t>
+              <a:t>The third mechanism, and the heart of the paper: memory.
+Everything an agent produces is written to one store: plans, conversations, reflections. Each entry has a category, a timestamp and an importance score.
+Everything also reads from that store. Planning retrieves relevant memories. Dialogue retrieves recent ones. Reflection compresses the important ones into a short insight and writes it back. That's the loop in the figure.
+Retrieval prefers recent and important entries, and the store stays bounded.
+Two notes. A person can write feedback into the same store. And the model is stateless — all continuity lives in memory.</a:t>
             </a:r>
             <a:endParaRPr lang="en-US" dirty="0"/>
           </a:p>
@@ -1502,10 +1502,10 @@
           <a:p>
             <a:r>
               <a:rPr lang="en-US" dirty="0"/>
-              <a:t>Before the demo, one look at that loop as the system runs it.
-An agent initialises from its profile and its memory. On day one there's nothing to reflect on yet, so it plans straight from the profile; on every later day it reflects on memory first, and that reflection feeds the planning call.
-From there: generate the plan, store it, pick the destination, move, and talk if someone else is there — and the conversation goes back into memory. A closed loop.
-Let me show you that running.</a:t>
+              <a:t>Here is that loop as the system runs it.
+An agent starts from its profile and its memory. On day one there's nothing to reflect on, so it plans from the profile. Later days reflect first, and the reflection feeds the plan.
+Then: plan, store it, pick a destination, move, talk if someone is there — and the conversation goes back into memory.
+Let me show you.</a:t>
             </a:r>
             <a:endParaRPr lang="en-US" dirty="0"/>
           </a:p>
@@ -1593,13 +1593,13 @@
           <a:p>
             <a:r>
               <a:rPr lang="en-US" dirty="0"/>
-              <a:t>▶ INSERT THE VIDEO OVER THE FRAME BEFORE THE TALK. Set it to start automatically, and check the sound is muted. Roughly 180 words over two minutes — leave gaps and let the town play.
+              <a:t>▶ INSERT THE VIDEO OVER THE FRAME BEFORE THE TALK. Set it to start automatically, and check the sound is muted. About 140 words over two minutes — leave gaps and let the town play.
 [start] So that's the loop. Here it is running.
-This is Valentown. The whole town sits on one plane: homes along the top, the café, the supermarket and the pharmacy below, a park on the left. Everything you're seeing was produced by the Python backend — the planning, the dialogue and the reflection, and the only calls to DeepSeek — and the client simply replays it.
-[~20 s] Watch one resident. He wakes up at home, and the schedule he generated at the start of the day sends him out to a destination. Nobody is steering him.
-[~50 s] Here two residents arrive at the same place in the same period — that's the co-location trigger firing. What they say is generated from their context and their recent memory, and it goes straight back into memory.
-[~1:30] And at the end of the day each agent reflects on what happened — the step you just saw in the flow chart — and that reflection is what tomorrow's plan is built on.
-[end] So the schedule, the trigger and the memory loop — everything from the last four slides — this is all of it, running.</a:t>
+This is Valentown. Homes along the top, café, supermarket and pharmacy below, a park on the left. Everything you see came from the Python backend — planning, dialogue, reflection, and the only calls to DeepSeek. The client just replays it.
+[~20 s] Watch one resident. He wakes at home, and his own schedule sends him out. Nobody is steering him.
+[~50 s] Now two residents reach the same place at the same time. That's the co-location trigger. What they say comes from their context and recent memory, and goes straight back into memory.
+[~1:30] At the end of the day each agent reflects — the step you saw in the flow chart — and tomorrow's plan is built on it.
+[end] Schedule, trigger, memory loop. Everything from the last four slides, running.</a:t>
             </a:r>
             <a:endParaRPr lang="en-US" dirty="0"/>
           </a:p>
@@ -1687,9 +1687,9 @@
           <a:p>
             <a:r>
               <a:rPr lang="en-US" dirty="0"/>
-              <a:t>For the experiments we instantiate the framework with seven agents: a supermarket owner, a pharmacist, a couple with a seven-year-old, a family teacher and an architect. Their attributes ground everything the model generates.
-We run several consecutive virtual days, each one a full cycle. Scheduling is deterministic while the content is stochastic — a reproducible pipeline with diverse behaviour inside it.
-And we're asking three questions: what interaction does, what memory does, and whether social structure emerges on its own.</a:t>
+              <a:t>We run seven agents: a supermarket owner, a pharmacist, a couple with a young son, a family teacher, an architect.
+The simulation runs several consecutive days, each a full cycle. Scheduling is deterministic, generated content is not — a reproducible pipeline with diverse behaviour.
+We ask three things: what interaction does, what memory does, and whether social structure emerges.</a:t>
             </a:r>
             <a:endParaRPr lang="en-US" dirty="0"/>
           </a:p>
@@ -1777,10 +1777,10 @@
           <a:p>
             <a:r>
               <a:rPr lang="en-US" dirty="0"/>
-              <a:t>The first experiment is an ablation on interaction.
-With interaction on, agents produce noticeably richer and more varied behaviour. The reason is mechanical, not mysterious: a conversation puts new context into memory, and memory is an input to the next plan. So what someone said to you yesterday shows up in what you do today. We see agents scheduling follow-ups, going back to the same places, and repeated contact reinforcing particular pairs.
-With interaction off, the town goes quiet. No new social information enters at all, so agents fall back on their initial goals, and schedules stay static day to day.
-So interaction isn't decoration here — it drives diversity and adaptation at the same time.</a:t>
+              <a:t>Our first experiment is an ablation on interaction.
+With interaction on, behaviour is clearly richer. The reason is mechanical: a conversation adds context to memory, and memory feeds the next plan. What someone said to you yesterday shows up in what you do today. Agents schedule follow-ups, revisit places, and specific pairs grow closer.
+With interaction off, the town goes quiet. No new social information arrives, agents fall back on their initial goals, and schedules stop changing.
+Interaction drives both diversity and adaptation.</a:t>
             </a:r>
             <a:endParaRPr lang="en-US" dirty="0"/>
           </a:p>

</xml_diff>